<commit_message>
v2: code-review fixes, demo, report
</commit_message>
<xml_diff>
--- a/deliverables/LMP_Milestone1.pptx
+++ b/deliverables/LMP_Milestone1.pptx
@@ -116,36 +116,36 @@
   <p:extLst>
     <p:ext uri="{521415D9-36F7-43E2-AB2F-B90AF26B5E84}">
       <p14:sectionLst xmlns:p14="http://schemas.microsoft.com/office/powerpoint/2010/main">
-        <p14:section name="Introduction" id="{ed807a0b-161e-feb2-66f6-f7f0f54db887}">
+        <p14:section name="Introduction" id="{3bd466e5-931d-a575-3cf2-71e7d57c3d07}">
           <p14:sldIdLst>
             <p14:sldId id="256"/>
           </p14:sldIdLst>
         </p14:section>
-        <p14:section name="Problem" id="{789f0647-7e5f-4249-bbc8-9b75692078a1}">
+        <p14:section name="Problem" id="{05e9ea98-036c-44c3-2169-fdbba40a6d67}">
           <p14:sldIdLst>
             <p14:sldId id="257"/>
             <p14:sldId id="258"/>
           </p14:sldIdLst>
         </p14:section>
-        <p14:section name="Review" id="{130299d7-c19f-f841-564d-bd7cede54e87}">
+        <p14:section name="Review" id="{10d819fb-55e5-c8c4-88db-7c9d67af1b4b}">
           <p14:sldIdLst>
             <p14:sldId id="259"/>
             <p14:sldId id="260"/>
           </p14:sldIdLst>
         </p14:section>
-        <p14:section name="Proposal" id="{1e826c2c-273d-1906-e506-e95c00f53227}">
+        <p14:section name="Proposal" id="{566a8a79-7fab-f4b3-f712-4765b2b0456e}">
           <p14:sldIdLst>
             <p14:sldId id="261"/>
             <p14:sldId id="262"/>
           </p14:sldIdLst>
         </p14:section>
-        <p14:section name="Results" id="{3c8e7d0d-614c-e181-82e1-1f61b8b2fd10}">
+        <p14:section name="Results" id="{01fc2c4d-5ea5-5faa-651c-280f4b8d1a2e}">
           <p14:sldIdLst>
             <p14:sldId id="263"/>
             <p14:sldId id="264"/>
           </p14:sldIdLst>
         </p14:section>
-        <p14:section name="Conclusion" id="{143c2adf-3a7f-354f-9730-fc9ffbadc22b}">
+        <p14:section name="Conclusion" id="{bd3faaf1-cd7a-a3ba-c7dc-3ae094eb6c2f}">
           <p14:sldIdLst>
             <p14:sldId id="265"/>
           </p14:sldIdLst>
@@ -1554,7 +1554,7 @@
           <a:p>
             <a:r>
               <a:rPr lang="en-US" dirty="0"/>
-              <a:t>Good morning. Our project asks a simple question with legal consequences: when a legal sentence is simplified, is its legal meaning still the same? We extend the JUDGEBERT metric (EMNLP 2025), which was built for French insurance text, to English and Hindi and to a new legal domain, and we add explanations of what changed.</a:t>
+              <a:t>[About 30 sec] Good morning. Our project asks a simple question with legal consequences: when a legal sentence is simplified, is its legal meaning still the same? We extend the JUDGEBERT metric (EMNLP 2025), which was built for French insurance text, to English and Hindi and to a new legal domain, and we add explanations of what changed.</a:t>
             </a:r>
             <a:endParaRPr lang="en-US" dirty="0"/>
           </a:p>
@@ -1642,7 +1642,7 @@
           <a:p>
             <a:r>
               <a:rPr lang="en-US" dirty="0"/>
-              <a:t>Experiment 5 looks inside the errors. The chart shows the mean predicted score for each gold error type. The gold scores, in dark, are low for every error type. The generic embedding score, in grey, stays around 6 to 7 for every type — it cannot tell a faithful rewrite from a negation or a changed number. Our LegalDiff model follows the gold pattern much more closely. The explanation module detects that a legal error exists with F1 0.79 and names the exact error type in 40 percent of error cases, across eleven classes. The cards show two correct explanations, one in Hindi, and one honest failure: when 'does not cover' becomes 'pays for', the negation is removed by changing the verb, which our lexicon does not capture. That points to the need for a pretrained encoder. In conclusion: generic similarity is not a legal-meaning metric, explicit legal-difference modelling is the strongest signal in both languages and even transfers to the French human-labelled data, and the JUDGEBERT-style encoder needs pretraining. The main caveat is that our labels are rubric-based silver labels; human double annotation is the next milestone. Thank you.</a:t>
+              <a:t>[About 1.5 min] Experiment 5 looks inside the errors. The chart shows the mean predicted score for each gold error type. The gold scores, in dark, are low for every error type. The generic embedding score, in grey, stays around 6 to 7 for every type — it cannot tell a faithful rewrite from a negation or a changed number. Our LegalDiff model follows the gold pattern much more closely. The explanation module detects that a legal error exists with F1 0.79 and names the exact error type in 40 percent of error cases, across eleven classes. The cards show two correct explanations, one in Hindi, and one honest failure: when 'does not cover' becomes 'pays for', the negation is removed by changing the verb, which our lexicon does not capture. That points to the need for a pretrained encoder. In conclusion: generic similarity is not a legal-meaning metric, explicit legal-difference modelling is the strongest signal in both languages and even transfers to the French human-labelled data, and the JUDGEBERT-style encoder needs pretraining. The main caveat is that our labels are rubric-based silver labels; human double annotation is the next milestone. Thank you.</a:t>
             </a:r>
             <a:endParaRPr lang="en-US" dirty="0"/>
           </a:p>
@@ -1730,7 +1730,7 @@
           <a:p>
             <a:r>
               <a:rPr lang="en-US" dirty="0"/>
-              <a:t>Plain-language rewriting of contracts and policies is now common, often done by LLMs. Here is a real pair from our dataset. Version B removes a single word, 'not', and turns an exclusion into coverage. A generic sentence-embedding similarity (WordLlama static embeddings) gives 0.85 and 0.84 — practically identical — while a lawyer would score A as 10 and B as 1. This is the problem we target.</a:t>
+              <a:t>[About 1 min] Plain-language rewriting of contracts and policies is now common, often done by LLMs. Here is a real pair from our dataset. Version B removes a single word, 'not', and turns an exclusion into coverage. A generic sentence-embedding similarity (WordLlama static embeddings) gives 0.85 and 0.84 — practically identical — while a lawyer would score A as 10 and B as 1. This is the problem we target.</a:t>
             </a:r>
             <a:endParaRPr lang="en-US" dirty="0"/>
           </a:p>
@@ -1818,7 +1818,7 @@
           <a:p>
             <a:r>
               <a:rPr lang="en-US" dirty="0"/>
-              <a:t>We analysed where legal meaning is lost and derived an eight-category taxonomy from the project brief. Each is a small surface edit with a large legal effect, which is why generic similarity fails. We then formalise the task: a scoring function f-theta maps an original and a simplification to an LMP score between 1 and 10; a decision rule turns the score into Preserved, Partially or Not preserved; and an explanation function returns the error type and a short rationale. Success is measured by correlation and RMSE against human LMP scores.</a:t>
+              <a:t>[About 1 min] We analysed where legal meaning is lost and derived an eight-category taxonomy from the project brief. Each is a small surface edit with a large legal effect, which is why generic similarity fails. We then formalise the task: a scoring function f-theta maps an original and a simplification to an LMP score between 1 and 10; a decision rule turns the score into Preserved, Partially or Not preserved; and an explanation function returns the error type and a short rationale. Success is measured by correlation and RMSE against human LMP scores.</a:t>
             </a:r>
             <a:endParaRPr lang="en-US" dirty="0"/>
           </a:p>
@@ -1906,7 +1906,7 @@
           <a:p>
             <a:r>
               <a:rPr lang="en-US" dirty="0"/>
-              <a:t>This table reviews eight representative systems in chronological order. Lexical metrics — BLEU, chrF, SARI — measure surface overlap. Embedding metrics like SBERT and BERTScore measure general semantic closeness, and we showed on slide 2 they cannot separate 'covers' from 'does not cover'. MeaningBERT learns meaning preservation but is not legal. LLM judges explain, but are costly and not reproducible. JUDGEBERT is the only legal-aware metric, but it is limited to French insurance and gives no reasons. That defines our research gap.</a:t>
+              <a:t>[About 1 min] This table reviews eight representative systems in chronological order. Lexical metrics — BLEU, chrF, SARI — measure surface overlap. Embedding metrics like SBERT and BERTScore measure general semantic closeness, and we showed on slide 2 they cannot separate 'covers' from 'does not cover'. MeaningBERT learns meaning preservation but is not legal. LLM judges explain, but are costly and not reproducible. JUDGEBERT is the only legal-aware metric, but it is limited to French insurance and gives no reasons. That defines our research gap.</a:t>
             </a:r>
             <a:endParaRPr lang="en-US" dirty="0"/>
           </a:p>
@@ -1994,7 +1994,7 @@
           <a:p>
             <a:r>
               <a:rPr lang="en-US" dirty="0"/>
-              <a:t>Our base paper, JUDGEBERT, defines Legal Meaning Preservation and releases FrJUDGE: 297 French insurance pairs, each scored 1 to 10 by five annotators — we verified this in the released data. Its model is a BERT regressor trained with identical and unrelated pairs as augmentation. The paper's own limitations — one language, one domain, small data, no out-of-domain test, no explanation — become our five extensions. The research question asks whether the approach transfers to Hindi and a new domain and beats generic similarity, and five objectives operationalise it.</a:t>
+              <a:t>[About 1 min] Our base paper, JUDGEBERT, defines Legal Meaning Preservation and releases FrJUDGE: 297 French insurance pairs, each scored 1 to 10 by five annotators — we verified this in the released data. Its model is a BERT regressor trained with identical and unrelated pairs as augmentation. The paper's own limitations — one language, one domain, small data, no out-of-domain test, no explanation — become our five extensions. The research question asks whether the approach transfers to Hindi and a new domain and beats generic similarity, and five objectives operationalise it.</a:t>
             </a:r>
             <a:endParaRPr lang="en-US" dirty="0"/>
           </a:p>
@@ -2082,7 +2082,7 @@
           <a:p>
             <a:r>
               <a:rPr lang="en-US" dirty="0"/>
-              <a:t>Methodology. Like JUDGEBERT, the model reads the original and the simplification together as one cross-encoded sequence, so attention can compare them token by token. We pool the CLS vector together with difference and product features of the two sentences. In parallel the LegalDiff extractor computes 19 interpretable legal-difference features in English and Hindi. A fusion head regresses the score on the 1–10 scale; a threshold rule gives the decision and the explainer the error type and reason. The dataset has 320 pairs plus 320 held-out sanity pairs. For this milestone the encoder is a 2-layer transformer trained from scratch on CPU, because pretrained-model downloads were unavailable; the GPU fine-tune of XLM-R or MuRIL is the next step.</a:t>
+              <a:t>[About 1.5 min] Methodology. Like JUDGEBERT, the model reads the original and the simplification together as one cross-encoded sequence, so attention can compare them token by token. We pool the CLS vector together with difference and product features of the two sentences. In parallel the LegalDiff extractor computes 19 interpretable legal-difference features in English and Hindi. A fusion head regresses the score on the 1–10 scale; a threshold rule gives the decision and the explainer the error type and reason. The dataset has 320 pairs plus 320 held-out sanity pairs. For this milestone the encoder is a 2-layer transformer trained from scratch on CPU, because pretrained-model downloads were unavailable; the GPU fine-tune of XLM-R or MuRIL is the next step.</a:t>
             </a:r>
             <a:endParaRPr lang="en-US" dirty="0"/>
           </a:p>
@@ -2170,7 +2170,7 @@
           <a:p>
             <a:r>
               <a:rPr lang="en-US" dirty="0"/>
-              <a:t>Each technique is justified by the problem. chrF works at character level, which suits Hindi morphology. Embedding cosine and BERTScore-style alignment are the generic similarity the brief asks us to beat. Gradient-boosted trees learn non-linear combinations of the sparse LegalDiff features from only a few hundred pairs, which is why that model is strongest today. The cross-encoder lets attention compare the two sentences token by token; its pretrained version will use XLM-R, which covers 100 languages, or MuRIL, trained on 17 Indian languages. The regression formulation matches JUDGEBERT, so our numbers are comparable. Augmentation anchors the scale, and LegalDiff makes predictions auditable. The bottom row defines the evaluation metrics we report: correlation, error, F1 and sanity rates.</a:t>
+              <a:t>[About 1 min] Each technique is justified by the problem. chrF works at character level, which suits Hindi morphology. Embedding cosine and BERTScore-style alignment are the generic similarity the brief asks us to beat. Gradient-boosted trees learn non-linear combinations of the sparse LegalDiff features from only a few hundred pairs, which is why that model is strongest today. The cross-encoder lets attention compare the two sentences token by token; its pretrained version will use XLM-R, which covers 100 languages, or MuRIL, trained on 17 Indian languages. The regression formulation matches JUDGEBERT, so our numbers are comparable. Augmentation anchors the scale, and LegalDiff makes predictions auditable. The bottom row defines the evaluation metrics we report: correlation, error, F1 and sanity rates.</a:t>
             </a:r>
             <a:endParaRPr lang="en-US" dirty="0"/>
           </a:p>
@@ -2258,7 +2258,7 @@
           <a:p>
             <a:r>
               <a:rPr lang="en-US" dirty="0"/>
-              <a:t>Experiment 1 compares three generic similarity baselines with three learned LMP models under 5-fold cross-validation grouped by clause, so the English and Hindi versions of a clause never sit in different folds. The legal-difference model LegalDiff-GBR is best on every metric: Pearson 0.60 against 0.37 for chrF, the strongest generic metric, and it is the only system that detects 'Not preserved' pairs reliably (F1 0.61). Generic baselines are calibrated to the 1–10 scale but cluster in the middle, so their decision F1 is near zero. The chart is Experiment 2's per-language view: embedding-based similarity loses almost half its correlation on Hindi, while LegalDiff stays at about 0.6 in both languages. Our JUDGEBERT-style encoder trained from scratch, without pretrained weights, does not learn on its own — r 0.12 — but fusing LegalDiff lifts it to 0.44. This tells us the architecture works when it has legal signal and that a pretrained multilingual encoder is the key next step.</a:t>
+              <a:t>[About 1.5 min] Experiment 1 compares three generic similarity baselines with three learned LMP models under 5-fold cross-validation grouped by clause, so the English and Hindi versions of a clause never sit in different folds. The legal-difference model LegalDiff-GBR is best on every metric: Pearson 0.60 against 0.37 for chrF, the strongest generic metric, and it is the only system that detects 'Not preserved' pairs reliably (F1 0.61). Generic baselines are calibrated to the 1–10 scale but cluster in the middle, so their decision F1 is near zero. The chart is Experiment 2's per-language view: embedding-based similarity loses almost half its correlation on Hindi, while LegalDiff stays at about 0.6 in both languages. Our JUDGEBERT-style encoder trained from scratch, without pretrained weights, does not learn on its own — r 0.12 — but fusing LegalDiff lifts it to 0.44. This tells us the architecture works when it has legal signal and that a pretrained multilingual encoder is the key next step.</a:t>
             </a:r>
             <a:endParaRPr lang="en-US" dirty="0"/>
           </a:p>
@@ -2346,7 +2346,7 @@
           <a:p>
             <a:r>
               <a:rPr lang="en-US" dirty="0"/>
-              <a:t>Left, Experiment 2: models trained on English only and tested on Hindi, and the reverse, on held-out clauses. LegalDiff transfers almost without loss — 0.48 and 0.54 — because its features are defined for both languages, while embedding cosine collapses to 0.04 on Hindi. Right, Experiment 3: training on insurance and testing on tenancy, or the reverse, costs at most 0.06 in correlation. The FrJUDGE rows are the strongest evidence: these are real human LMP judgements from the base paper, in French. Models trained only on our English–Hindi data reach 0.56 to 0.59, above every generic metric, and embedding cosine is negatively correlated. Bottom, Experiment 4: the sanity checks from JUDGEBERT. Our augmented models give identical pairs about 10 and unrelated pairs between 1.2 and 1.7, whereas generic embeddings give unrelated Hindi sentences 6.6 out of 10 — a clear failure.</a:t>
+              <a:t>[About 1 min] Left, Experiment 2: models trained on English only and tested on Hindi, and the reverse, on held-out clauses. LegalDiff transfers almost without loss — 0.48 and 0.54 — because its features are defined for both languages, while embedding cosine collapses to 0.04 on Hindi. Right, Experiment 3: training on insurance and testing on tenancy, or the reverse, costs at most 0.06 in correlation. The FrJUDGE rows are the strongest evidence: these are real human LMP judgements from the base paper, in French. Models trained only on our English–Hindi data reach 0.56 to 0.59, above every generic metric, and embedding cosine is negatively correlated. Bottom, Experiment 4: the sanity checks from JUDGEBERT. Our augmented models give identical pairs about 10 and unrelated pairs between 1.2 and 1.7, whereas generic embeddings give unrelated Hindi sentences 6.6 out of 10 — a clear failure.</a:t>
             </a:r>
             <a:endParaRPr lang="en-US" dirty="0"/>
           </a:p>
@@ -3073,8 +3073,8 @@
         </p:nvSpPr>
         <p:spPr>
           <a:xfrm>
-            <a:off x="457200" y="2743200"/>
-            <a:ext cx="5669280" cy="594360"/>
+            <a:off x="457200" y="2487168"/>
+            <a:ext cx="8229600" cy="411480"/>
           </a:xfrm>
           <a:prstGeom prst="rect">
             <a:avLst/>
@@ -3090,14 +3090,14 @@
               <a:buNone/>
             </a:pPr>
             <a:r>
-              <a:rPr lang="en-US" sz="1500" i="1" dirty="0">
+              <a:rPr lang="en-US" sz="1400" i="1" dirty="0">
                 <a:solidFill>
                   <a:srgbClr val="CADCEB"/>
                 </a:solidFill>
               </a:rPr>
-              <a:t>Does a simplified legal sentence still say the same thing in law? An English + Hindi extension of JUDGEBERT, with full experimental results (E1–E5)</a:t>
+              <a:t>An English + Hindi extension of JUDGEBERT that scores, decides and explains legal meaning</a:t>
             </a:r>
-            <a:endParaRPr lang="en-US" sz="1500" dirty="0"/>
+            <a:endParaRPr lang="en-US" sz="1400" dirty="0"/>
           </a:p>
         </p:txBody>
       </p:sp>
@@ -3109,8 +3109,8 @@
         </p:nvSpPr>
         <p:spPr>
           <a:xfrm>
-            <a:off x="6720840" y="1051560"/>
-            <a:ext cx="1737360" cy="1737360"/>
+            <a:off x="6903720" y="868680"/>
+            <a:ext cx="1508760" cy="1508760"/>
           </a:xfrm>
           <a:prstGeom prst="ellipse">
             <a:avLst/>
@@ -3137,8 +3137,8 @@
         </p:blipFill>
         <p:spPr>
           <a:xfrm>
-            <a:off x="7132320" y="1463040"/>
-            <a:ext cx="914400" cy="914400"/>
+            <a:off x="7269480" y="1234440"/>
+            <a:ext cx="777240" cy="777240"/>
           </a:xfrm>
           <a:prstGeom prst="rect">
             <a:avLst/>
@@ -3147,18 +3147,18 @@
       </p:pic>
       <p:sp>
         <p:nvSpPr>
-          <p:cNvPr id="7" name="title-info-card"/>
+          <p:cNvPr id="7" name="kpi-0"/>
           <p:cNvSpPr/>
           <p:nvPr/>
         </p:nvSpPr>
         <p:spPr>
           <a:xfrm>
-            <a:off x="457200" y="3611880"/>
-            <a:ext cx="8229600" cy="1097280"/>
+            <a:off x="457200" y="3017520"/>
+            <a:ext cx="2651760" cy="731520"/>
           </a:xfrm>
           <a:prstGeom prst="roundRect">
             <a:avLst>
-              <a:gd name="adj" fmla="val 6667"/>
+              <a:gd name="adj" fmla="val 10000"/>
             </a:avLst>
           </a:prstGeom>
           <a:solidFill>
@@ -3175,8 +3175,299 @@
         </p:nvSpPr>
         <p:spPr>
           <a:xfrm>
-            <a:off x="685800" y="3675888"/>
-            <a:ext cx="7863840" cy="960120"/>
+            <a:off x="594360" y="3044952"/>
+            <a:ext cx="2377440" cy="384048"/>
+          </a:xfrm>
+          <a:prstGeom prst="rect">
+            <a:avLst/>
+          </a:prstGeom>
+          <a:noFill/>
+          <a:ln/>
+        </p:spPr>
+        <p:txBody>
+          <a:bodyPr wrap="square" lIns="0" tIns="0" rIns="0" bIns="0" rtlCol="0" anchor="ctr"/>
+          <a:lstStyle/>
+          <a:p>
+            <a:pPr indent="0" marL="0">
+              <a:buNone/>
+            </a:pPr>
+            <a:r>
+              <a:rPr lang="en-US" sz="2200" b="1" dirty="0">
+                <a:solidFill>
+                  <a:schemeClr val="accent1"/>
+                </a:solidFill>
+                <a:latin typeface="Cambria" pitchFamily="34" charset="0"/>
+                <a:ea typeface="Cambria" pitchFamily="34" charset="-122"/>
+                <a:cs typeface="Cambria" pitchFamily="34" charset="-120"/>
+              </a:rPr>
+              <a:t>320</a:t>
+            </a:r>
+            <a:endParaRPr lang="en-US" sz="2200" dirty="0"/>
+          </a:p>
+        </p:txBody>
+      </p:sp>
+      <p:sp>
+        <p:nvSpPr>
+          <p:cNvPr id="9" name="Text 6"/>
+          <p:cNvSpPr txBox="1"/>
+          <p:nvPr/>
+        </p:nvSpPr>
+        <p:spPr>
+          <a:xfrm>
+            <a:off x="594360" y="3429000"/>
+            <a:ext cx="2423160" cy="274320"/>
+          </a:xfrm>
+          <a:prstGeom prst="rect">
+            <a:avLst/>
+          </a:prstGeom>
+          <a:noFill/>
+          <a:ln/>
+        </p:spPr>
+        <p:txBody>
+          <a:bodyPr wrap="square" lIns="0" tIns="0" rIns="0" bIns="0" rtlCol="0" anchor="ctr"/>
+          <a:lstStyle/>
+          <a:p>
+            <a:pPr indent="0" marL="0">
+              <a:buNone/>
+            </a:pPr>
+            <a:r>
+              <a:rPr lang="en-US" sz="1050" dirty="0">
+                <a:solidFill>
+                  <a:srgbClr val="CADCEB"/>
+                </a:solidFill>
+              </a:rPr>
+              <a:t>parallel EN–HI legal pairs, 2 domains</a:t>
+            </a:r>
+            <a:endParaRPr lang="en-US" sz="1050" dirty="0"/>
+          </a:p>
+        </p:txBody>
+      </p:sp>
+      <p:sp>
+        <p:nvSpPr>
+          <p:cNvPr id="10" name="kpi-1"/>
+          <p:cNvSpPr/>
+          <p:nvPr/>
+        </p:nvSpPr>
+        <p:spPr>
+          <a:xfrm>
+            <a:off x="3246120" y="3017520"/>
+            <a:ext cx="2651760" cy="731520"/>
+          </a:xfrm>
+          <a:prstGeom prst="roundRect">
+            <a:avLst>
+              <a:gd name="adj" fmla="val 10000"/>
+            </a:avLst>
+          </a:prstGeom>
+          <a:solidFill>
+            <a:srgbClr val="24364F"/>
+          </a:solidFill>
+          <a:ln/>
+        </p:spPr>
+      </p:sp>
+      <p:sp>
+        <p:nvSpPr>
+          <p:cNvPr id="11" name="Text 8"/>
+          <p:cNvSpPr txBox="1"/>
+          <p:nvPr/>
+        </p:nvSpPr>
+        <p:spPr>
+          <a:xfrm>
+            <a:off x="3383280" y="3044952"/>
+            <a:ext cx="2377440" cy="384048"/>
+          </a:xfrm>
+          <a:prstGeom prst="rect">
+            <a:avLst/>
+          </a:prstGeom>
+          <a:noFill/>
+          <a:ln/>
+        </p:spPr>
+        <p:txBody>
+          <a:bodyPr wrap="square" lIns="0" tIns="0" rIns="0" bIns="0" rtlCol="0" anchor="ctr"/>
+          <a:lstStyle/>
+          <a:p>
+            <a:pPr indent="0" marL="0">
+              <a:buNone/>
+            </a:pPr>
+            <a:r>
+              <a:rPr lang="en-US" sz="2200" b="1" dirty="0">
+                <a:solidFill>
+                  <a:schemeClr val="accent1"/>
+                </a:solidFill>
+                <a:latin typeface="Cambria" pitchFamily="34" charset="0"/>
+                <a:ea typeface="Cambria" pitchFamily="34" charset="-122"/>
+                <a:cs typeface="Cambria" pitchFamily="34" charset="-120"/>
+              </a:rPr>
+              <a:t>0.60 vs 0.37</a:t>
+            </a:r>
+            <a:endParaRPr lang="en-US" sz="2200" dirty="0"/>
+          </a:p>
+        </p:txBody>
+      </p:sp>
+      <p:sp>
+        <p:nvSpPr>
+          <p:cNvPr id="12" name="Text 9"/>
+          <p:cNvSpPr txBox="1"/>
+          <p:nvPr/>
+        </p:nvSpPr>
+        <p:spPr>
+          <a:xfrm>
+            <a:off x="3383280" y="3429000"/>
+            <a:ext cx="2423160" cy="274320"/>
+          </a:xfrm>
+          <a:prstGeom prst="rect">
+            <a:avLst/>
+          </a:prstGeom>
+          <a:noFill/>
+          <a:ln/>
+        </p:spPr>
+        <p:txBody>
+          <a:bodyPr wrap="square" lIns="0" tIns="0" rIns="0" bIns="0" rtlCol="0" anchor="ctr"/>
+          <a:lstStyle/>
+          <a:p>
+            <a:pPr indent="0" marL="0">
+              <a:buNone/>
+            </a:pPr>
+            <a:r>
+              <a:rPr lang="en-US" sz="1050" dirty="0">
+                <a:solidFill>
+                  <a:srgbClr val="CADCEB"/>
+                </a:solidFill>
+              </a:rPr>
+              <a:t>legal-aware vs best generic metric (r)</a:t>
+            </a:r>
+            <a:endParaRPr lang="en-US" sz="1050" dirty="0"/>
+          </a:p>
+        </p:txBody>
+      </p:sp>
+      <p:sp>
+        <p:nvSpPr>
+          <p:cNvPr id="13" name="kpi-2"/>
+          <p:cNvSpPr/>
+          <p:nvPr/>
+        </p:nvSpPr>
+        <p:spPr>
+          <a:xfrm>
+            <a:off x="6035040" y="3017520"/>
+            <a:ext cx="2651760" cy="731520"/>
+          </a:xfrm>
+          <a:prstGeom prst="roundRect">
+            <a:avLst>
+              <a:gd name="adj" fmla="val 10000"/>
+            </a:avLst>
+          </a:prstGeom>
+          <a:solidFill>
+            <a:srgbClr val="24364F"/>
+          </a:solidFill>
+          <a:ln/>
+        </p:spPr>
+      </p:sp>
+      <p:sp>
+        <p:nvSpPr>
+          <p:cNvPr id="14" name="Text 11"/>
+          <p:cNvSpPr txBox="1"/>
+          <p:nvPr/>
+        </p:nvSpPr>
+        <p:spPr>
+          <a:xfrm>
+            <a:off x="6172200" y="3044952"/>
+            <a:ext cx="2377440" cy="384048"/>
+          </a:xfrm>
+          <a:prstGeom prst="rect">
+            <a:avLst/>
+          </a:prstGeom>
+          <a:noFill/>
+          <a:ln/>
+        </p:spPr>
+        <p:txBody>
+          <a:bodyPr wrap="square" lIns="0" tIns="0" rIns="0" bIns="0" rtlCol="0" anchor="ctr"/>
+          <a:lstStyle/>
+          <a:p>
+            <a:pPr indent="0" marL="0">
+              <a:buNone/>
+            </a:pPr>
+            <a:r>
+              <a:rPr lang="en-US" sz="2200" b="1" dirty="0">
+                <a:solidFill>
+                  <a:schemeClr val="accent1"/>
+                </a:solidFill>
+                <a:latin typeface="Cambria" pitchFamily="34" charset="0"/>
+                <a:ea typeface="Cambria" pitchFamily="34" charset="-122"/>
+                <a:cs typeface="Cambria" pitchFamily="34" charset="-120"/>
+              </a:rPr>
+              <a:t>0.59</a:t>
+            </a:r>
+            <a:endParaRPr lang="en-US" sz="2200" dirty="0"/>
+          </a:p>
+        </p:txBody>
+      </p:sp>
+      <p:sp>
+        <p:nvSpPr>
+          <p:cNvPr id="15" name="Text 12"/>
+          <p:cNvSpPr txBox="1"/>
+          <p:nvPr/>
+        </p:nvSpPr>
+        <p:spPr>
+          <a:xfrm>
+            <a:off x="6172200" y="3429000"/>
+            <a:ext cx="2423160" cy="274320"/>
+          </a:xfrm>
+          <a:prstGeom prst="rect">
+            <a:avLst/>
+          </a:prstGeom>
+          <a:noFill/>
+          <a:ln/>
+        </p:spPr>
+        <p:txBody>
+          <a:bodyPr wrap="square" lIns="0" tIns="0" rIns="0" bIns="0" rtlCol="0" anchor="ctr"/>
+          <a:lstStyle/>
+          <a:p>
+            <a:pPr indent="0" marL="0">
+              <a:buNone/>
+            </a:pPr>
+            <a:r>
+              <a:rPr lang="en-US" sz="1050" dirty="0">
+                <a:solidFill>
+                  <a:srgbClr val="CADCEB"/>
+                </a:solidFill>
+              </a:rPr>
+              <a:t>zero-shot r on human-scored French data</a:t>
+            </a:r>
+            <a:endParaRPr lang="en-US" sz="1050" dirty="0"/>
+          </a:p>
+        </p:txBody>
+      </p:sp>
+      <p:sp>
+        <p:nvSpPr>
+          <p:cNvPr id="16" name="title-info-card"/>
+          <p:cNvSpPr/>
+          <p:nvPr/>
+        </p:nvSpPr>
+        <p:spPr>
+          <a:xfrm>
+            <a:off x="457200" y="3886200"/>
+            <a:ext cx="8229600" cy="822960"/>
+          </a:xfrm>
+          <a:prstGeom prst="roundRect">
+            <a:avLst>
+              <a:gd name="adj" fmla="val 8889"/>
+            </a:avLst>
+          </a:prstGeom>
+          <a:solidFill>
+            <a:srgbClr val="24364F"/>
+          </a:solidFill>
+          <a:ln/>
+        </p:spPr>
+      </p:sp>
+      <p:sp>
+        <p:nvSpPr>
+          <p:cNvPr id="17" name="Text 14"/>
+          <p:cNvSpPr txBox="1"/>
+          <p:nvPr/>
+        </p:nvSpPr>
+        <p:spPr>
+          <a:xfrm>
+            <a:off x="685800" y="3931920"/>
+            <a:ext cx="7863840" cy="731520"/>
           </a:xfrm>
           <a:prstGeom prst="rect">
             <a:avLst/>
@@ -3247,23 +3538,6 @@
               </a:rPr>
               <a:t>Dr. Surabhi Solanki · Dr. Ankur</a:t>
             </a:r>
-            <a:endParaRPr lang="en-US" sz="1300" dirty="0"/>
-          </a:p>
-          <a:p>
-            <a:pPr indent="0" marL="0">
-              <a:spcAft>
-                <a:spcPts val="200"/>
-              </a:spcAft>
-              <a:buNone/>
-            </a:pPr>
-            <a:r>
-              <a:rPr lang="en-US" sz="1300" b="1" dirty="0">
-                <a:solidFill>
-                  <a:srgbClr val="C8892B"/>
-                </a:solidFill>
-              </a:rPr>
-              <a:t>Venue: </a:t>
-            </a:r>
             <a:pPr indent="0" marL="0">
               <a:spcAft>
                 <a:spcPts val="200"/>
@@ -3273,10 +3547,10 @@
             <a:r>
               <a:rPr lang="en-US" sz="1300" dirty="0">
                 <a:solidFill>
-                  <a:srgbClr val="FFFFFF"/>
+                  <a:srgbClr val="CADCEB"/>
                 </a:solidFill>
               </a:rPr>
-              <a:t>Lab BLA-211-B · 14 October 2026 · 10:00 AM – 12:00 PM</a:t>
+              <a:t>   |   Lab BLA-211-B · 14 Oct 2026, 10:00 AM</a:t>
             </a:r>
             <a:endParaRPr lang="en-US" sz="1300" dirty="0"/>
           </a:p>
@@ -3434,7 +3708,7 @@
         <p:spPr>
           <a:xfrm>
             <a:off x="5522976" y="1325880"/>
-            <a:ext cx="932688" cy="347472"/>
+            <a:ext cx="932688" cy="365760"/>
           </a:xfrm>
           <a:prstGeom prst="rect">
             <a:avLst/>
@@ -3450,14 +3724,14 @@
               <a:buNone/>
             </a:pPr>
             <a:r>
-              <a:rPr lang="en-US" sz="900" dirty="0">
+              <a:rPr lang="en-US" sz="1000" dirty="0">
                 <a:solidFill>
                   <a:schemeClr val="tx2"/>
                 </a:solidFill>
               </a:rPr>
               <a:t>error-detection F1</a:t>
             </a:r>
-            <a:endParaRPr lang="en-US" sz="900" dirty="0"/>
+            <a:endParaRPr lang="en-US" sz="1000" dirty="0"/>
           </a:p>
         </p:txBody>
       </p:sp>
@@ -3531,7 +3805,7 @@
         <p:spPr>
           <a:xfrm>
             <a:off x="6601968" y="1325880"/>
-            <a:ext cx="932688" cy="347472"/>
+            <a:ext cx="932688" cy="365760"/>
           </a:xfrm>
           <a:prstGeom prst="rect">
             <a:avLst/>
@@ -3547,14 +3821,14 @@
               <a:buNone/>
             </a:pPr>
             <a:r>
-              <a:rPr lang="en-US" sz="900" dirty="0">
+              <a:rPr lang="en-US" sz="1000" dirty="0">
                 <a:solidFill>
                   <a:schemeClr val="tx2"/>
                 </a:solidFill>
               </a:rPr>
               <a:t>error type correct</a:t>
             </a:r>
-            <a:endParaRPr lang="en-US" sz="900" dirty="0"/>
+            <a:endParaRPr lang="en-US" sz="1000" dirty="0"/>
           </a:p>
         </p:txBody>
       </p:sp>
@@ -3628,7 +3902,7 @@
         <p:spPr>
           <a:xfrm>
             <a:off x="7680960" y="1325880"/>
-            <a:ext cx="932688" cy="347472"/>
+            <a:ext cx="932688" cy="365760"/>
           </a:xfrm>
           <a:prstGeom prst="rect">
             <a:avLst/>
@@ -3644,14 +3918,14 @@
               <a:buNone/>
             </a:pPr>
             <a:r>
-              <a:rPr lang="en-US" sz="900" dirty="0">
+              <a:rPr lang="en-US" sz="1000" dirty="0">
                 <a:solidFill>
                   <a:schemeClr val="tx2"/>
                 </a:solidFill>
               </a:rPr>
               <a:t>type macro-F1 (11)</a:t>
             </a:r>
-            <a:endParaRPr lang="en-US" sz="900" dirty="0"/>
+            <a:endParaRPr lang="en-US" sz="1000" dirty="0"/>
           </a:p>
         </p:txBody>
       </p:sp>
@@ -3726,14 +4000,14 @@
               <a:buNone/>
             </a:pPr>
             <a:r>
-              <a:rPr lang="en-US" sz="900" dirty="0">
+              <a:rPr lang="en-US" sz="1000" dirty="0">
                 <a:solidFill>
                   <a:schemeClr val="tx1"/>
                 </a:solidFill>
               </a:rPr>
-              <a:t>Correct · HI · Negation (gold 1). “…आपूर्ति… नहीं काटेगा” → “…काट सकता है”. Emb. cos 7.0 | ours 4.5 → NEGATION: “negation removed, reversing the rule”.</a:t>
+              <a:t>Correct · HI · Negation (gold 1): “नहीं काटेगा” → “काट सकता है”. Emb. cos 7.0 | ours 4.5 → NEGATION, rule reversed.</a:t>
             </a:r>
-            <a:endParaRPr lang="en-US" sz="900" dirty="0"/>
+            <a:endParaRPr lang="en-US" sz="1000" dirty="0"/>
           </a:p>
         </p:txBody>
       </p:sp>
@@ -3808,14 +4082,14 @@
               <a:buNone/>
             </a:pPr>
             <a:r>
-              <a:rPr lang="en-US" sz="900" dirty="0">
+              <a:rPr lang="en-US" sz="1000" dirty="0">
                 <a:solidFill>
                   <a:schemeClr val="tx1"/>
                 </a:solidFill>
               </a:rPr>
-              <a:t>Correct · EN · Number (gold 2). Deductible Rs 5,000 → Rs 50,000. Emb. cos 6.6 | ours 5.3 → NUMBER: “Amount changed: 5000 → 50000”.</a:t>
+              <a:t>Correct · EN · Number (gold 2): deductible Rs 5,000 → Rs 50,000. Emb. cos 6.6 | ours 5.3 → NUMBER: 5000 → 50000.</a:t>
             </a:r>
-            <a:endParaRPr lang="en-US" sz="900" dirty="0"/>
+            <a:endParaRPr lang="en-US" sz="1000" dirty="0"/>
           </a:p>
         </p:txBody>
       </p:sp>
@@ -3890,14 +4164,14 @@
               <a:buNone/>
             </a:pPr>
             <a:r>
-              <a:rPr lang="en-US" sz="900" dirty="0">
+              <a:rPr lang="en-US" sz="1000" dirty="0">
                 <a:solidFill>
                   <a:schemeClr val="tx1"/>
                 </a:solidFill>
               </a:rPr>
-              <a:t>Missed · EN · Negation (gold 1). “does not cover” → “pays for”. Emb. cos 6.1 | ours 8.9 → missed: polarity flipped by a verb change, not by “not”.</a:t>
+              <a:t>Missed · EN · Negation (gold 1): “does not cover” → “pays for”. Emb. cos 6.1 | ours 8.9: polarity flipped by a verb, not “not”.</a:t>
             </a:r>
-            <a:endParaRPr lang="en-US" sz="900" dirty="0"/>
+            <a:endParaRPr lang="en-US" sz="1000" dirty="0"/>
           </a:p>
         </p:txBody>
       </p:sp>
@@ -4059,14 +4333,14 @@
               <a:buNone/>
             </a:pPr>
             <a:r>
-              <a:rPr lang="en-US" sz="950" b="1" dirty="0">
+              <a:rPr lang="en-US" sz="1050" b="1" dirty="0">
                 <a:solidFill>
                   <a:schemeClr val="accent1"/>
                 </a:solidFill>
               </a:rPr>
               <a:t>Next (M2–M3): human annotation + α → XLM-R / MuRIL fine-tune → IEEE paper + GitHub</a:t>
             </a:r>
-            <a:endParaRPr lang="en-US" sz="950" dirty="0"/>
+            <a:endParaRPr lang="en-US" sz="1050" dirty="0"/>
           </a:p>
         </p:txBody>
       </p:sp>
@@ -11854,28 +12128,28 @@
               <a:buNone/>
             </a:pPr>
             <a:r>
-              <a:rPr lang="en-US" sz="950" dirty="0">
+              <a:rPr lang="en-US" sz="1000" dirty="0">
                 <a:solidFill>
                   <a:srgbClr val="2E4057"/>
                 </a:solidFill>
               </a:rPr>
               <a:t>original o</a:t>
             </a:r>
-            <a:endParaRPr lang="en-US" sz="950" dirty="0"/>
+            <a:endParaRPr lang="en-US" sz="1000" dirty="0"/>
           </a:p>
           <a:p>
             <a:pPr algn="ctr" indent="0" marL="0">
               <a:buNone/>
             </a:pPr>
             <a:r>
-              <a:rPr lang="en-US" sz="950" dirty="0">
+              <a:rPr lang="en-US" sz="1000" dirty="0">
                 <a:solidFill>
                   <a:srgbClr val="2E4057"/>
                 </a:solidFill>
               </a:rPr>
               <a:t>simplification s</a:t>
             </a:r>
-            <a:endParaRPr lang="en-US" sz="950" dirty="0"/>
+            <a:endParaRPr lang="en-US" sz="1000" dirty="0"/>
           </a:p>
         </p:txBody>
       </p:sp>
@@ -11962,28 +12236,28 @@
               <a:buNone/>
             </a:pPr>
             <a:r>
-              <a:rPr lang="en-US" sz="950" dirty="0">
+              <a:rPr lang="en-US" sz="1000" dirty="0">
                 <a:solidFill>
                   <a:srgbClr val="2E4057"/>
                 </a:solidFill>
               </a:rPr>
               <a:t>[CLS] o [SEP] s [SEP]</a:t>
             </a:r>
-            <a:endParaRPr lang="en-US" sz="950" dirty="0"/>
+            <a:endParaRPr lang="en-US" sz="1000" dirty="0"/>
           </a:p>
           <a:p>
             <a:pPr algn="ctr" indent="0" marL="0">
               <a:buNone/>
             </a:pPr>
             <a:r>
-              <a:rPr lang="en-US" sz="950" dirty="0">
+              <a:rPr lang="en-US" sz="1000" dirty="0">
                 <a:solidFill>
                   <a:srgbClr val="2E4057"/>
                 </a:solidFill>
               </a:rPr>
               <a:t>shared EN/HI BPE</a:t>
             </a:r>
-            <a:endParaRPr lang="en-US" sz="950" dirty="0"/>
+            <a:endParaRPr lang="en-US" sz="1000" dirty="0"/>
           </a:p>
         </p:txBody>
       </p:sp>
@@ -12070,14 +12344,14 @@
               <a:buNone/>
             </a:pPr>
             <a:r>
-              <a:rPr lang="en-US" sz="950" dirty="0">
+              <a:rPr lang="en-US" sz="1000" dirty="0">
                 <a:solidFill>
                   <a:srgbClr val="2E4057"/>
                 </a:solidFill>
               </a:rPr>
               <a:t>self-attention across o and s</a:t>
             </a:r>
-            <a:endParaRPr lang="en-US" sz="950" dirty="0"/>
+            <a:endParaRPr lang="en-US" sz="1000" dirty="0"/>
           </a:p>
         </p:txBody>
       </p:sp>
@@ -12164,14 +12438,14 @@
               <a:buNone/>
             </a:pPr>
             <a:r>
-              <a:rPr lang="en-US" sz="950" dirty="0">
+              <a:rPr lang="en-US" sz="1000" dirty="0">
                 <a:solidFill>
                   <a:srgbClr val="2E4057"/>
                 </a:solidFill>
               </a:rPr>
               <a:t>h_CLS, u−v, u⊙v, |u−v|</a:t>
             </a:r>
-            <a:endParaRPr lang="en-US" sz="950" dirty="0"/>
+            <a:endParaRPr lang="en-US" sz="1000" dirty="0"/>
           </a:p>
         </p:txBody>
       </p:sp>
@@ -12258,14 +12532,14 @@
               <a:buNone/>
             </a:pPr>
             <a:r>
-              <a:rPr lang="en-US" sz="950" dirty="0">
+              <a:rPr lang="en-US" sz="1000" dirty="0">
                 <a:solidFill>
                   <a:srgbClr val="2E4057"/>
                 </a:solidFill>
               </a:rPr>
               <a:t>modality · negation · numbers · durations · parties · conditions · exceptions · scope</a:t>
             </a:r>
-            <a:endParaRPr lang="en-US" sz="950" dirty="0"/>
+            <a:endParaRPr lang="en-US" sz="1000" dirty="0"/>
           </a:p>
         </p:txBody>
       </p:sp>
@@ -18414,7 +18688,7 @@
         <p:spPr>
           <a:xfrm>
             <a:off x="457200" y="3273552"/>
-            <a:ext cx="5074920" cy="384048"/>
+            <a:ext cx="5074920" cy="438912"/>
           </a:xfrm>
           <a:prstGeom prst="rect">
             <a:avLst/>
@@ -18430,14 +18704,14 @@
               <a:buNone/>
             </a:pPr>
             <a:r>
-              <a:rPr lang="en-US" sz="950" i="1" dirty="0">
+              <a:rPr lang="en-US" sz="1000" i="1" dirty="0">
                 <a:solidFill>
                   <a:schemeClr val="accent5"/>
                 </a:solidFill>
               </a:rPr>
               <a:t>Learned models: mean ± s.d. over 3 seeds. Baselines calibrated to 1–10 on training folds. Dec. F1 = macro-F1 of the 3-way decision; NP-F1 = F1 for ‘Not preserved’.</a:t>
             </a:r>
-            <a:endParaRPr lang="en-US" sz="950" dirty="0"/>
+            <a:endParaRPr lang="en-US" sz="1000" dirty="0"/>
           </a:p>
         </p:txBody>
       </p:sp>

</xml_diff>